<commit_message>
Update PPT generator: slides 12/14/15/17 reflect current project state
- Slide 12: Research results now shows redesigned structure (Hero + 5-grid + HISP featured)
- Slide 14: Added wp:html requirement, deploy.sh pipeline, page-map.json
- Slide 15: Updated directory tree with all 13 page dirs, full CSS prefix table
- Slide 17: Phase 1-7 all marked completed, Phase 8 in progress
- Regenerated .pptx file (19 slides)

https://claude.ai/code/session_01EGyEsgKQW4Zf8WXxaUtDhh
</commit_message>
<xml_diff>
--- a/docs/website-architecture-presentation.pptx
+++ b/docs/website-architecture-presentation.pptx
@@ -4501,7 +4501,7 @@
               </a:defRPr>
             </a:pPr>
             <a:r>
-              <a:t>焦點團體會議紀錄</a:t>
+              <a:t>焦點團體會議紀錄 + 核心倡議主張</a:t>
             </a:r>
           </a:p>
           <a:p>
@@ -4516,7 +4516,7 @@
               </a:defRPr>
             </a:pPr>
             <a:r>
-              <a:t>頁面底部：政策連署 + 社群分享按鈕</a:t>
+              <a:t>四大結構性問題卡片：職災隱形化、高齡化、安全網不足、健康識能落差</a:t>
             </a:r>
           </a:p>
           <a:p>
@@ -4543,7 +4543,7 @@
               </a:defRPr>
             </a:pPr>
             <a:r>
-              <a:t>07 研究成果：</a:t>
+              <a:t>07 研究成果（已重新設計）：</a:t>
             </a:r>
           </a:p>
           <a:p>
@@ -4558,7 +4558,7 @@
               </a:defRPr>
             </a:pPr>
             <a:r>
-              <a:t>嚴格 APA 第 7 版格式排版</a:t>
+              <a:t>Hero 含介紹文字、3 組統計、行動按鈕</a:t>
             </a:r>
           </a:p>
           <a:p>
@@ -4573,7 +4573,7 @@
               </a:defRPr>
             </a:pPr>
             <a:r>
-              <a:t>每筆文獻附 [PDF 下載, X.X MB] 按鈕</a:t>
+              <a:t>成果分類五宮格 + HISP 季會發表精選</a:t>
             </a:r>
           </a:p>
           <a:p>
@@ -4588,7 +4588,7 @@
               </a:defRPr>
             </a:pPr>
             <a:r>
-              <a:t>整合 Spotify / Apple Podcast 嵌入代碼</a:t>
+              <a:t>研究取徑四宮格：田野調查 / 量化分析 / 醫學專業 / 社會倡議</a:t>
             </a:r>
           </a:p>
           <a:p>
@@ -4603,7 +4603,7 @@
               </a:defRPr>
             </a:pPr>
             <a:r>
-              <a:t>子頁面：下載專區｜圖文資訊｜Podcast｜相關資源｜研究出版</a:t>
+              <a:t>子頁面：研究出版｜影音 Podcast｜圖文資訊｜下載專區｜相關資源</a:t>
             </a:r>
           </a:p>
         </p:txBody>
@@ -5826,7 +5826,7 @@
               </a:defRPr>
             </a:pPr>
             <a:r>
-              <a:t>HTML 區塊直貼 WordPress 程式碼編輯器（無需額外部署）</a:t>
+              <a:t>所有 HTML 必須用 &lt;!-- wp:html --&gt; 包裹（關鍵！否則 CSS 會失效）</a:t>
             </a:r>
           </a:p>
           <a:p>
@@ -5898,7 +5898,7 @@
               </a:defRPr>
             </a:pPr>
             <a:r>
-              <a:t>CSS 前綴隔離策略（如 gh- / mach- / ppe-）防止跨頁衝突</a:t>
+              <a:t>CSS 前綴隔離策略（13 組前綴）防止跨頁衝突</a:t>
             </a:r>
           </a:p>
           <a:p>
@@ -6012,7 +6012,52 @@
               </a:defRPr>
             </a:pPr>
             <a:r>
-              <a:t>WordPress 嵌入規範：禁止 body/html/全域重置等覆蓋主題樣式的寫法</a:t>
+              <a:t>部署流程：</a:t>
+            </a:r>
+          </a:p>
+          <a:p>
+            <a:pPr lvl="1">
+              <a:spcAft>
+                <a:spcPts val="800"/>
+              </a:spcAft>
+              <a:defRPr sz="1600">
+                <a:solidFill>
+                  <a:srgbClr val="1F2937"/>
+                </a:solidFill>
+              </a:defRPr>
+            </a:pPr>
+            <a:r>
+              <a:t>scripts/deploy.sh 三階段自動部署（CSS → Shortcodes → HTML）</a:t>
+            </a:r>
+          </a:p>
+          <a:p>
+            <a:pPr lvl="1">
+              <a:spcAft>
+                <a:spcPts val="800"/>
+              </a:spcAft>
+              <a:defRPr sz="1600">
+                <a:solidFill>
+                  <a:srgbClr val="1F2937"/>
+                </a:solidFill>
+              </a:defRPr>
+            </a:pPr>
+            <a:r>
+              <a:t>scripts/page-map.json 對應 HTML 檔案 → WordPress 頁面 ID</a:t>
+            </a:r>
+          </a:p>
+          <a:p>
+            <a:pPr lvl="1">
+              <a:spcAft>
+                <a:spcPts val="800"/>
+              </a:spcAft>
+              <a:defRPr sz="1600">
+                <a:solidFill>
+                  <a:srgbClr val="1F2937"/>
+                </a:solidFill>
+              </a:defRPr>
+            </a:pPr>
+            <a:r>
+              <a:t>禁止 body{} / html{} / *{} 等全域選擇器覆蓋主題樣式</a:t>
             </a:r>
           </a:p>
         </p:txBody>
@@ -6247,7 +6292,7 @@
               </a:defRPr>
             </a:pPr>
             <a:r>
-              <a:t>docs/          — 架構藍圖、設計規格文件</a:t>
+              <a:t>docs/           — 架構藍圖、設計規格（architecture.md 必讀）</a:t>
             </a:r>
           </a:p>
           <a:p>
@@ -6262,7 +6307,7 @@
               </a:defRPr>
             </a:pPr>
             <a:r>
-              <a:t>css/           — global.css 全站設計 Token</a:t>
+              <a:t>css/            — global.css 全站設計 Token</a:t>
             </a:r>
           </a:p>
           <a:p>
@@ -6277,7 +6322,7 @@
               </a:defRPr>
             </a:pPr>
             <a:r>
-              <a:t>pages/         — 各頁面 HTML 區塊</a:t>
+              <a:t>pages/          — 各頁面 HTML 區塊</a:t>
             </a:r>
           </a:p>
           <a:p>
@@ -6292,7 +6337,7 @@
               </a:defRPr>
             </a:pPr>
             <a:r>
-              <a:t>  ├── About/            — 01 關於計畫</a:t>
+              <a:t>  home/ About/ occupational-safety/ healthgood/</a:t>
             </a:r>
           </a:p>
           <a:p>
@@ -6307,7 +6352,7 @@
               </a:defRPr>
             </a:pPr>
             <a:r>
-              <a:t>  ├── occupational-safety/ — 02 職業安全（含子頁）</a:t>
+              <a:t>  economic-insurance/ farmer-study/ dignity-farming-initiative/</a:t>
             </a:r>
           </a:p>
           <a:p>
@@ -6322,7 +6367,7 @@
               </a:defRPr>
             </a:pPr>
             <a:r>
-              <a:t>  ├── beginner-farmers/  — 新手務農</a:t>
+              <a:t>  research-result/（含 5 子頁）thenews/</a:t>
             </a:r>
           </a:p>
           <a:p>
@@ -6337,7 +6382,7 @@
               </a:defRPr>
             </a:pPr>
             <a:r>
-              <a:t>  ├── young-farmers/     — 青農</a:t>
+              <a:t>  beginner-farmers/ young-farmers/ experienced-farmers/ Public/</a:t>
             </a:r>
           </a:p>
           <a:p>
@@ -6352,7 +6397,7 @@
               </a:defRPr>
             </a:pPr>
             <a:r>
-              <a:t>  ├── Public/            — 一般民眾</a:t>
+              <a:t>shortcodes/     — WordPress PHP 短代碼（由 Code Snippets 插件管理）</a:t>
             </a:r>
           </a:p>
           <a:p>
@@ -6367,7 +6412,34 @@
               </a:defRPr>
             </a:pPr>
             <a:r>
-              <a:t>  └── shared/            — 共用元件（sidebar）</a:t>
+              <a:t>scripts/        — deploy.sh、page-map.json、generate_pptx.py</a:t>
+            </a:r>
+          </a:p>
+          <a:p>
+            <a:pPr>
+              <a:spcAft>
+                <a:spcPts val="800"/>
+              </a:spcAft>
+              <a:defRPr sz="1600">
+                <a:solidFill>
+                  <a:srgbClr val="1F2937"/>
+                </a:solidFill>
+              </a:defRPr>
+            </a:pPr>
+          </a:p>
+          <a:p>
+            <a:pPr>
+              <a:spcAft>
+                <a:spcPts val="800"/>
+              </a:spcAft>
+              <a:defRPr sz="1600">
+                <a:solidFill>
+                  <a:srgbClr val="1F2937"/>
+                </a:solidFill>
+              </a:defRPr>
+            </a:pPr>
+            <a:r>
+              <a:t>CSS 前綴隔離（13 組）：</a:t>
             </a:r>
           </a:p>
           <a:p>
@@ -6382,7 +6454,7 @@
               </a:defRPr>
             </a:pPr>
             <a:r>
-              <a:t>shortcodes/    — WordPress PHP 短代碼</a:t>
+              <a:t>prev- 職安 ｜ hp- 健康 ｜ money- 經濟 ｜ adv- 倡議 ｜ res- 研究</a:t>
             </a:r>
           </a:p>
           <a:p>
@@ -6397,7 +6469,7 @@
               </a:defRPr>
             </a:pPr>
             <a:r>
-              <a:t>scripts/       — 部署與匯入腳本</a:t>
+              <a:t>gh- 溫室 ｜ mach- 農機 ｜ ppe- 防護 ｜ pod- Podcast</a:t>
             </a:r>
           </a:p>
           <a:p>
@@ -6412,79 +6484,7 @@
               </a:defRPr>
             </a:pPr>
             <a:r>
-              <a:t>imports/       — 批次匯入 HTML 暫存區</a:t>
-            </a:r>
-          </a:p>
-          <a:p>
-            <a:pPr>
-              <a:spcAft>
-                <a:spcPts val="800"/>
-              </a:spcAft>
-              <a:defRPr sz="1600">
-                <a:solidFill>
-                  <a:srgbClr val="1F2937"/>
-                </a:solidFill>
-              </a:defRPr>
-            </a:pPr>
-          </a:p>
-          <a:p>
-            <a:pPr>
-              <a:spcAft>
-                <a:spcPts val="800"/>
-              </a:spcAft>
-              <a:defRPr sz="1600">
-                <a:solidFill>
-                  <a:srgbClr val="1F2937"/>
-                </a:solidFill>
-              </a:defRPr>
-            </a:pPr>
-            <a:r>
-              <a:t>PHP Shortcodes：</a:t>
-            </a:r>
-          </a:p>
-          <a:p>
-            <a:pPr lvl="1">
-              <a:spcAft>
-                <a:spcPts val="800"/>
-              </a:spcAft>
-              <a:defRPr sz="1600">
-                <a:solidFill>
-                  <a:srgbClr val="1F2937"/>
-                </a:solidFill>
-              </a:defRPr>
-            </a:pPr>
-            <a:r>
-              <a:t>新聞迴圈（my_news_loop）｜Podcast 網格（knowledge_podcast_grid）</a:t>
-            </a:r>
-          </a:p>
-          <a:p>
-            <a:pPr lvl="1">
-              <a:spcAft>
-                <a:spcPts val="800"/>
-              </a:spcAft>
-              <a:defRPr sz="1600">
-                <a:solidFill>
-                  <a:srgbClr val="1F2937"/>
-                </a:solidFill>
-              </a:defRPr>
-            </a:pPr>
-            <a:r>
-              <a:t>天氣小工具（weather_widget）｜FB 動態牆（fb_feed_widget）</a:t>
-            </a:r>
-          </a:p>
-          <a:p>
-            <a:pPr lvl="1">
-              <a:spcAft>
-                <a:spcPts val="800"/>
-              </a:spcAft>
-              <a:defRPr sz="1600">
-                <a:solidFill>
-                  <a:srgbClr val="1F2937"/>
-                </a:solidFill>
-              </a:defRPr>
-            </a:pPr>
-            <a:r>
-              <a:t>首頁亮點輪播（home_highlight_slider）｜雜誌式新聞版面（news_magazine_layout）</a:t>
+              <a:t>start- 新手 ｜ young- 青農 ｜ senior- 資深 ｜ public- 公眾</a:t>
             </a:r>
           </a:p>
         </p:txBody>
@@ -7142,7 +7142,7 @@
               </a:defRPr>
             </a:pPr>
             <a:r>
-              <a:t>Phase 1</a:t>
+              <a:t>Phase 1-2</a:t>
             </a:r>
           </a:p>
           <a:p>
@@ -7154,7 +7154,7 @@
               </a:defRPr>
             </a:pPr>
             <a:r>
-              <a:t>已完成</a:t>
+              <a:t>✅ 已完成</a:t>
             </a:r>
           </a:p>
           <a:p>
@@ -7178,7 +7178,15 @@
               </a:defRPr>
             </a:pPr>
             <a:r>
-              <a:t>首頁：身分導航 + 三大核心主題</a:t>
+              <a:t>首頁 + 側邊欄</a:t>
+            </a:r>
+            <a:br/>
+            <a:r>
+              <a:t>職業安全主頁</a:t>
+            </a:r>
+            <a:br/>
+            <a:r>
+              <a:t>+ 3 子頁 + 國際數據</a:t>
             </a:r>
           </a:p>
         </p:txBody>
@@ -7192,6 +7200,198 @@
         <p:spPr>
           <a:xfrm>
             <a:off x="3474720" y="1645920"/>
+            <a:ext cx="2560320" cy="4114800"/>
+          </a:xfrm>
+          <a:prstGeom prst="roundRect">
+            <a:avLst/>
+          </a:prstGeom>
+          <a:solidFill>
+            <a:srgbClr val="10B981"/>
+          </a:solidFill>
+          <a:ln>
+            <a:noFill/>
+          </a:ln>
+        </p:spPr>
+        <p:style>
+          <a:lnRef idx="1">
+            <a:schemeClr val="accent1"/>
+          </a:lnRef>
+          <a:fillRef idx="3">
+            <a:schemeClr val="accent1"/>
+          </a:fillRef>
+          <a:effectRef idx="2">
+            <a:schemeClr val="accent1"/>
+          </a:effectRef>
+          <a:fontRef idx="minor">
+            <a:schemeClr val="lt1"/>
+          </a:fontRef>
+        </p:style>
+        <p:txBody>
+          <a:bodyPr rtlCol="0" anchor="ctr" wrap="square"/>
+          <a:lstStyle/>
+          <a:p>
+            <a:pPr algn="ctr">
+              <a:defRPr sz="2000" b="1">
+                <a:solidFill>
+                  <a:srgbClr val="FFFFFF"/>
+                </a:solidFill>
+              </a:defRPr>
+            </a:pPr>
+            <a:r>
+              <a:t>Phase 3-4</a:t>
+            </a:r>
+          </a:p>
+          <a:p>
+            <a:pPr algn="ctr">
+              <a:defRPr sz="1400">
+                <a:solidFill>
+                  <a:srgbClr val="EEEEEE"/>
+                </a:solidFill>
+              </a:defRPr>
+            </a:pPr>
+            <a:r>
+              <a:t>✅ 已完成</a:t>
+            </a:r>
+          </a:p>
+          <a:p>
+            <a:pPr algn="ctr">
+              <a:defRPr sz="1000">
+                <a:solidFill>
+                  <a:srgbClr val="CCCCCC"/>
+                </a:solidFill>
+              </a:defRPr>
+            </a:pPr>
+            <a:r>
+              <a:t>─────</a:t>
+            </a:r>
+          </a:p>
+          <a:p>
+            <a:pPr algn="ctr">
+              <a:defRPr sz="1300">
+                <a:solidFill>
+                  <a:srgbClr val="FFFFFF"/>
+                </a:solidFill>
+              </a:defRPr>
+            </a:pPr>
+            <a:r>
+              <a:t>健康促進 + 4 子頁</a:t>
+            </a:r>
+            <a:br/>
+            <a:r>
+              <a:t>經濟與保險 + 5 子頁</a:t>
+            </a:r>
+            <a:br/>
+            <a:r>
+              <a:t>含互動試算器</a:t>
+            </a:r>
+          </a:p>
+        </p:txBody>
+      </p:sp>
+      <p:sp>
+        <p:nvSpPr>
+          <p:cNvPr id="7" name="Rounded Rectangle 6"/>
+          <p:cNvSpPr/>
+          <p:nvPr/>
+        </p:nvSpPr>
+        <p:spPr>
+          <a:xfrm>
+            <a:off x="6309360" y="1645920"/>
+            <a:ext cx="2560320" cy="4114800"/>
+          </a:xfrm>
+          <a:prstGeom prst="roundRect">
+            <a:avLst/>
+          </a:prstGeom>
+          <a:solidFill>
+            <a:srgbClr val="10B981"/>
+          </a:solidFill>
+          <a:ln>
+            <a:noFill/>
+          </a:ln>
+        </p:spPr>
+        <p:style>
+          <a:lnRef idx="1">
+            <a:schemeClr val="accent1"/>
+          </a:lnRef>
+          <a:fillRef idx="3">
+            <a:schemeClr val="accent1"/>
+          </a:fillRef>
+          <a:effectRef idx="2">
+            <a:schemeClr val="accent1"/>
+          </a:effectRef>
+          <a:fontRef idx="minor">
+            <a:schemeClr val="lt1"/>
+          </a:fontRef>
+        </p:style>
+        <p:txBody>
+          <a:bodyPr rtlCol="0" anchor="ctr" wrap="square"/>
+          <a:lstStyle/>
+          <a:p>
+            <a:pPr algn="ctr">
+              <a:defRPr sz="2000" b="1">
+                <a:solidFill>
+                  <a:srgbClr val="FFFFFF"/>
+                </a:solidFill>
+              </a:defRPr>
+            </a:pPr>
+            <a:r>
+              <a:t>Phase 5-7</a:t>
+            </a:r>
+          </a:p>
+          <a:p>
+            <a:pPr algn="ctr">
+              <a:defRPr sz="1400">
+                <a:solidFill>
+                  <a:srgbClr val="EEEEEE"/>
+                </a:solidFill>
+              </a:defRPr>
+            </a:pPr>
+            <a:r>
+              <a:t>✅ 已完成</a:t>
+            </a:r>
+          </a:p>
+          <a:p>
+            <a:pPr algn="ctr">
+              <a:defRPr sz="1000">
+                <a:solidFill>
+                  <a:srgbClr val="CCCCCC"/>
+                </a:solidFill>
+              </a:defRPr>
+            </a:pPr>
+            <a:r>
+              <a:t>─────</a:t>
+            </a:r>
+          </a:p>
+          <a:p>
+            <a:pPr algn="ctr">
+              <a:defRPr sz="1300">
+                <a:solidFill>
+                  <a:srgbClr val="FFFFFF"/>
+                </a:solidFill>
+              </a:defRPr>
+            </a:pPr>
+            <a:r>
+              <a:t>尊嚴農業倡議</a:t>
+            </a:r>
+            <a:br/>
+            <a:r>
+              <a:t>研究成果 + 5 子頁</a:t>
+            </a:r>
+            <a:br/>
+            <a:r>
+              <a:t>四大分眾入口</a:t>
+            </a:r>
+          </a:p>
+        </p:txBody>
+      </p:sp>
+      <p:sp>
+        <p:nvSpPr>
+          <p:cNvPr id="8" name="Rounded Rectangle 7"/>
+          <p:cNvSpPr/>
+          <p:nvPr/>
+        </p:nvSpPr>
+        <p:spPr>
+          <a:xfrm>
+            <a:off x="9144000" y="1645920"/>
             <a:ext cx="2560320" cy="4114800"/>
           </a:xfrm>
           <a:prstGeom prst="roundRect">
@@ -7230,7 +7430,7 @@
               </a:defRPr>
             </a:pPr>
             <a:r>
-              <a:t>Phase 2</a:t>
+              <a:t>Phase 8</a:t>
             </a:r>
           </a:p>
           <a:p>
@@ -7242,7 +7442,7 @@
               </a:defRPr>
             </a:pPr>
             <a:r>
-              <a:t>進行中</a:t>
+              <a:t>🔄 進行中</a:t>
             </a:r>
           </a:p>
           <a:p>
@@ -7266,203 +7466,15 @@
               </a:defRPr>
             </a:pPr>
             <a:r>
-              <a:t>職業安全頁面重建</a:t>
+              <a:t>農學堂 LMS</a:t>
             </a:r>
             <a:br/>
             <a:r>
-              <a:t>（主頁 + 溫室 + 省工農機 + PPE）</a:t>
-            </a:r>
-          </a:p>
-        </p:txBody>
-      </p:sp>
-      <p:sp>
-        <p:nvSpPr>
-          <p:cNvPr id="7" name="Rounded Rectangle 6"/>
-          <p:cNvSpPr/>
-          <p:nvPr/>
-        </p:nvSpPr>
-        <p:spPr>
-          <a:xfrm>
-            <a:off x="6309360" y="1645920"/>
-            <a:ext cx="2560320" cy="4114800"/>
-          </a:xfrm>
-          <a:prstGeom prst="roundRect">
-            <a:avLst/>
-          </a:prstGeom>
-          <a:solidFill>
-            <a:srgbClr val="F59E0B"/>
-          </a:solidFill>
-          <a:ln>
-            <a:noFill/>
-          </a:ln>
-        </p:spPr>
-        <p:style>
-          <a:lnRef idx="1">
-            <a:schemeClr val="accent1"/>
-          </a:lnRef>
-          <a:fillRef idx="3">
-            <a:schemeClr val="accent1"/>
-          </a:fillRef>
-          <a:effectRef idx="2">
-            <a:schemeClr val="accent1"/>
-          </a:effectRef>
-          <a:fontRef idx="minor">
-            <a:schemeClr val="lt1"/>
-          </a:fontRef>
-        </p:style>
-        <p:txBody>
-          <a:bodyPr rtlCol="0" anchor="ctr" wrap="square"/>
-          <a:lstStyle/>
-          <a:p>
-            <a:pPr algn="ctr">
-              <a:defRPr sz="2000" b="1">
-                <a:solidFill>
-                  <a:srgbClr val="FFFFFF"/>
-                </a:solidFill>
-              </a:defRPr>
-            </a:pPr>
-            <a:r>
-              <a:t>Phase 3</a:t>
-            </a:r>
-          </a:p>
-          <a:p>
-            <a:pPr algn="ctr">
-              <a:defRPr sz="1400">
-                <a:solidFill>
-                  <a:srgbClr val="EEEEEE"/>
-                </a:solidFill>
-              </a:defRPr>
-            </a:pPr>
-            <a:r>
-              <a:t>待啟動</a:t>
-            </a:r>
-          </a:p>
-          <a:p>
-            <a:pPr algn="ctr">
-              <a:defRPr sz="1000">
-                <a:solidFill>
-                  <a:srgbClr val="CCCCCC"/>
-                </a:solidFill>
-              </a:defRPr>
-            </a:pPr>
-            <a:r>
-              <a:t>─────</a:t>
-            </a:r>
-          </a:p>
-          <a:p>
-            <a:pPr algn="ctr">
-              <a:defRPr sz="1300">
-                <a:solidFill>
-                  <a:srgbClr val="FFFFFF"/>
-                </a:solidFill>
-              </a:defRPr>
-            </a:pPr>
-            <a:r>
-              <a:t>健康促進</a:t>
+              <a:t>部署自動化</a:t>
             </a:r>
             <a:br/>
             <a:r>
-              <a:t>（人體圖 + 職醫地圖）</a:t>
-            </a:r>
-            <a:br/>
-            <a:r>
-              <a:t>經濟試算器</a:t>
-            </a:r>
-          </a:p>
-        </p:txBody>
-      </p:sp>
-      <p:sp>
-        <p:nvSpPr>
-          <p:cNvPr id="8" name="Rounded Rectangle 7"/>
-          <p:cNvSpPr/>
-          <p:nvPr/>
-        </p:nvSpPr>
-        <p:spPr>
-          <a:xfrm>
-            <a:off x="9144000" y="1645920"/>
-            <a:ext cx="2560320" cy="4114800"/>
-          </a:xfrm>
-          <a:prstGeom prst="roundRect">
-            <a:avLst/>
-          </a:prstGeom>
-          <a:solidFill>
-            <a:srgbClr val="6B7280"/>
-          </a:solidFill>
-          <a:ln>
-            <a:noFill/>
-          </a:ln>
-        </p:spPr>
-        <p:style>
-          <a:lnRef idx="1">
-            <a:schemeClr val="accent1"/>
-          </a:lnRef>
-          <a:fillRef idx="3">
-            <a:schemeClr val="accent1"/>
-          </a:fillRef>
-          <a:effectRef idx="2">
-            <a:schemeClr val="accent1"/>
-          </a:effectRef>
-          <a:fontRef idx="minor">
-            <a:schemeClr val="lt1"/>
-          </a:fontRef>
-        </p:style>
-        <p:txBody>
-          <a:bodyPr rtlCol="0" anchor="ctr" wrap="square"/>
-          <a:lstStyle/>
-          <a:p>
-            <a:pPr algn="ctr">
-              <a:defRPr sz="2000" b="1">
-                <a:solidFill>
-                  <a:srgbClr val="FFFFFF"/>
-                </a:solidFill>
-              </a:defRPr>
-            </a:pPr>
-            <a:r>
-              <a:t>Phase 4</a:t>
-            </a:r>
-          </a:p>
-          <a:p>
-            <a:pPr algn="ctr">
-              <a:defRPr sz="1400">
-                <a:solidFill>
-                  <a:srgbClr val="EEEEEE"/>
-                </a:solidFill>
-              </a:defRPr>
-            </a:pPr>
-            <a:r>
-              <a:t>規劃中</a:t>
-            </a:r>
-          </a:p>
-          <a:p>
-            <a:pPr algn="ctr">
-              <a:defRPr sz="1000">
-                <a:solidFill>
-                  <a:srgbClr val="CCCCCC"/>
-                </a:solidFill>
-              </a:defRPr>
-            </a:pPr>
-            <a:r>
-              <a:t>─────</a:t>
-            </a:r>
-          </a:p>
-          <a:p>
-            <a:pPr algn="ctr">
-              <a:defRPr sz="1300">
-                <a:solidFill>
-                  <a:srgbClr val="FFFFFF"/>
-                </a:solidFill>
-              </a:defRPr>
-            </a:pPr>
-            <a:r>
-              <a:t>分眾入口頁面</a:t>
-            </a:r>
-            <a:br/>
-            <a:r>
-              <a:t>農學堂 LMS</a:t>
-            </a:r>
-            <a:br/>
-            <a:r>
-              <a:t>研究成果資料庫</a:t>
+              <a:t>持續優化</a:t>
             </a:r>
           </a:p>
         </p:txBody>

</xml_diff>